<commit_message>
docs(nanog98): scrub talk folder for the public repo
Remove internal workflow files (V15/V16 change and truth-check notes,
paste notes, run of show) and the v15 deck PDF. Strip run, snapshot,
network and CHG identifiers, the Predict-harness and gate-design text,
the pre-talk and to-confirm blocks and the archive and drafts links from
the README, cue card (MD and PDF) and speaker notes. Slides are unchanged.

Co-Authored-By: Claude Haiku 5.5 <noreply@anthropic.com>
Claude-Session: https://claude.ai/code/session_01GUocV5Xkg4bPJqTybkkZky
</commit_message>
<xml_diff>
--- a/docs/talks/nanog98/NANOG98_Digital_Twins_Talk_v16_notes.pptx
+++ b/docs/talks/nanog98/NANOG98_Digital_Twins_Talk_v16_notes.pptx
@@ -965,7 +965,7 @@
           <a:p/>
           <a:p>
             <a:r>
-              <a:t>Base snapshot 13984, from the lab. Change set CHG-752 stages one CLI line on ce-svc. Predicted snapshot 13985 shows that line removed and one added. TCP 443 is delivered on the baseline and dropped at ce-branch in the prediction. Eight of 56 subnet pairs are newly isolated, none newly connected.</a:t>
+              <a:t>The base snapshot is from the lab. The change set stages one CLI line on ce-svc. The predicted snapshot shows that line removed and one added. TCP 443 is delivered on the baseline and dropped at ce-branch in the prediction. Eight of 56 subnet pairs are newly isolated, none newly connected.</a:t>
             </a:r>
           </a:p>
           <a:p/>
@@ -975,11 +975,6 @@
             </a:r>
           </a:p>
           <a:p/>
-          <a:p>
-            <a:r>
-              <a:t>Captured 2026-10-04, not yet matched to the run record. If asked which Forward build, say the 26.9 line, not a build number, until I have.</a:t>
-            </a:r>
-          </a:p>
           <a:p/>
           <a:p>
             <a:r>
@@ -1271,7 +1266,7 @@
           <a:p/>
           <a:p>
             <a:r>
-              <a:t>Failure impact is the question I'd put to a model. I am not showing that run, so I won't claim one. Demo 4 is the lab side of it.</a:t>
+              <a:t>Failure impact is the question I'd put to a model. I am not showing that run, so I won't claim one.</a:t>
             </a:r>
           </a:p>
           <a:p/>
@@ -1483,7 +1478,7 @@
           <a:p/>
           <a:p>
             <a:r>
-              <a:t>CLICK CUES: 1 disappear, 2 break, 3 job, 4 the fix card (run 2aa18f9f).</a:t>
+              <a:t>CLICK CUES: 1 disappear, 2 break, 3 job, 4 the fix card.</a:t>
             </a:r>
           </a:p>
           <a:p/>
@@ -1565,7 +1560,7 @@
           <a:p/>
           <a:p>
             <a:r>
-              <a:t>PLAY THE CLIP (68 seconds). Break run b6f0435e, fix run 2aa18f9f. HELD 4 to 11 s: the planted digit, undone platform-side because PAN-OS has no commit-confirm. REVERTED 11 to 18 s: snapshot 14840 restored, 14841 after. Evidence 18 to 25 s: 118 checks, 2 regressions, pd3_fwin_h_to_fwout_h pass to fail. Break PR comment 25 to 32 s. Fix HELD 32 to 38 s. CONFIRMED 38 to 45 s, 14844 to 14845. Evidence 45 to 51 s. Fix PR comment 51 to 58 s. Close 58 to 68 s.</a:t>
+              <a:t>PLAY THE CLIP (68 seconds). HELD 4 to 11 s: the planted digit, undone platform-side because PAN-OS has no commit-confirm. REVERTED 11 to 18 s: the pre-change snapshot restored. Evidence 18 to 25 s: 118 checks, 2 regressions, one check going from pass to fail. Break PR comment 25 to 32 s. Fix HELD 32 to 38 s. CONFIRMED 38 to 45 s. Evidence 45 to 51 s. Fix PR comment 51 to 58 s. Close 58 to 68 s.</a:t>
             </a:r>
           </a:p>
           <a:p/>
@@ -1771,7 +1766,7 @@
           <a:p/>
           <a:p>
             <a:r>
-              <a:t>Pre-flight, proven live on 2026-10-10, run b9a03a53. Held before any device was touched. Off by default.</a:t>
+              <a:t>Pre-flight, proven live on 2026-10-10. Held before any device was touched. Off by default.</a:t>
             </a:r>
           </a:p>
           <a:p/>
@@ -1871,7 +1866,7 @@
           <a:p/>
           <a:p>
             <a:r>
-              <a:t>Built, run once: one vendor-neutral intent. The live run, 394f25f2-4260-45c2-a576-3492c420bf89, applied the good version, and Forward confirmed it, 118 of 118. The shared pack still uses the old form. A prototype matched 59 of 60 comparisons on six fleet40 changes.</a:t>
+              <a:t>Built, run once: one vendor-neutral intent. A live run applied the good version, and Forward confirmed it, 118 of 118. The shared deployment pack still uses the old form. A prototype matched 59 of 60 comparisons on six changes from the 40-branch fleet.</a:t>
             </a:r>
           </a:p>
           <a:p/>
@@ -2463,11 +2458,6 @@
             </a:r>
           </a:p>
           <a:p/>
-          <a:p>
-            <a:r>
-              <a:t>IF ASKED, the Predict harness. One lab, one change, run 2026-10-16. A design and a first slice, not a benchmark. It found a real defect in our napalm change path. On a two-device change, the second device failed, the first device's running config dropped from 116 lines to 54, and the run still reported it reverted. The fix is merged; undo proof pending. Predict gave no verdict on the EOS change: the live pre-flight only stages PAN-OS rules, so it recorded skipped.</a:t>
-            </a:r>
-          </a:p>
           <a:p/>
           <a:p>
             <a:r>
@@ -2629,7 +2619,7 @@
           <a:p/>
           <a:p>
             <a:r>
-              <a:t>The firewall change from demo 3 as one intent, from the design draft. The planted fault is a one-line patch: the break variant overrides dst with the lower half of the range. The reachable and path entries are where checks and Predict probes would come from. The firewall policy plugin is ours, not stock netlab, so the names are netlab-style, not upstream. The position field and the idea of removal are names I invented, because netlab has none. Designed and prototyped, not shipped.</a:t>
+              <a:t>The firewall change from demo 3 as one intent, from the design. The planted fault is a one-line patch: the break variant overrides dst with the lower half of the range. The reachable and path entries are where checks and Predict probes would come from. The firewall policy plugin is ours, not stock netlab, so the names are netlab-style, not upstream. The position field and the idea of removal are names I invented, because netlab has none. Designed and prototyped, not shipped.</a:t>
             </a:r>
           </a:p>
           <a:p/>
@@ -2811,7 +2801,7 @@
           <a:p/>
           <a:p>
             <a:r>
-              <a:t>Two comments on pull request #27. Break, run b6f0435e: REVERTED, not applied, with the reasons and Forward's advisory AI summary. Fix, run 2aa18f9f: APPLIED and CONFIRMED, status check green, sweep 118 of 118, 0 regressions. The pending Predict pre-flight line is expected: the pre-flight is off by default.</a:t>
+              <a:t>Two comments on the pull request. Break: REVERTED, not applied, with the reasons and Forward's advisory AI summary. Fix: APPLIED and CONFIRMED, status check green, sweep 118 of 118, 0 regressions. The pending Predict pre-flight line is expected: the pre-flight is off by default.</a:t>
             </a:r>
           </a:p>
           <a:p/>
@@ -3081,15 +3071,10 @@
           <a:p/>
           <a:p>
             <a:r>
-              <a:t>The honest version of "AI is not an executor." Something proposes a change. A person approves it by merging in Forgejo, bound to an exact head, so an edit after approval is a new approval. Approval issues one single-use receipt that expires, and any drift voids it. Reversible chat actions can run without that. Irreversible actions are refused without a reviewed approval.</a:t>
-            </a:r>
-          </a:p>
-          <a:p/>
-          <a:p>
-            <a:r>
-              <a:t>Today the gate is armed for one action, extending a lease. I found and fixed a bug in the gate where arming one action pulled others into its path. A gate you have not tested adversarially is a gate you do not have.</a:t>
-            </a:r>
-          </a:p>
+              <a:t>AI can propose a change. A person approves it before anything is applied. Autonomous execution is off.</a:t>
+            </a:r>
+          </a:p>
+          <a:p/>
           <a:p/>
           <a:p>
             <a:r>

</xml_diff>